<commit_message>
fix: Force forecast table to true ECMWF 9km model via dropdown & update PPT for 12-16 Oct
</commit_message>
<xml_diff>
--- a/WX_UPDATE_12_OCT_2026_TO_16_OCT_2026.pptx
+++ b/WX_UPDATE_12_OCT_2026_TO_16_OCT_2026.pptx
@@ -8739,7 +8739,7 @@
                         <a:rPr sz="1200">
                           <a:latin typeface="Arial"/>
                         </a:rPr>
-                        <a:t>50%</a:t>
+                        <a:t>20%</a:t>
                       </a:r>
                       <a:endParaRPr b="1" sz="850" u="none" cap="none" strike="noStrike"/>
                     </a:p>
@@ -8836,11 +8836,11 @@
                       <a:r>
                         <a:rPr sz="1200" b="1">
                           <a:solidFill>
-                            <a:srgbClr val="FFC000"/>
+                            <a:srgbClr val="00B050"/>
                           </a:solidFill>
                           <a:latin typeface="Arial"/>
                         </a:rPr>
-                        <a:t>LTD GO</a:t>
+                        <a:t>GO</a:t>
                       </a:r>
                       <a:endParaRPr b="1" sz="850" u="none" cap="none" strike="noStrike">
                         <a:solidFill>
@@ -9153,7 +9153,7 @@
                         <a:rPr sz="1200">
                           <a:latin typeface="Arial"/>
                         </a:rPr>
-                        <a:t>0mm</a:t>
+                        <a:t>0.5mm</a:t>
                       </a:r>
                       <a:endParaRPr sz="1400" u="none" cap="none" strike="noStrike"/>
                     </a:p>
@@ -9251,7 +9251,7 @@
                         <a:rPr sz="1200">
                           <a:latin typeface="Arial"/>
                         </a:rPr>
-                        <a:t>50%</a:t>
+                        <a:t>85%</a:t>
                       </a:r>
                       <a:endParaRPr sz="1400" u="none" cap="none" strike="noStrike"/>
                     </a:p>
@@ -9665,7 +9665,7 @@
                         <a:rPr sz="1200">
                           <a:latin typeface="Arial"/>
                         </a:rPr>
-                        <a:t>0mm</a:t>
+                        <a:t>0.7mm</a:t>
                       </a:r>
                       <a:endParaRPr sz="1400" u="none" cap="none" strike="noStrike"/>
                     </a:p>
@@ -9763,7 +9763,7 @@
                         <a:rPr sz="1200">
                           <a:latin typeface="Arial"/>
                         </a:rPr>
-                        <a:t>50%</a:t>
+                        <a:t>85%</a:t>
                       </a:r>
                       <a:endParaRPr sz="1400" u="none" cap="none" strike="noStrike"/>
                     </a:p>
@@ -10177,7 +10177,7 @@
                         <a:rPr sz="1200">
                           <a:latin typeface="Arial"/>
                         </a:rPr>
-                        <a:t>0mm</a:t>
+                        <a:t>1.4mm</a:t>
                       </a:r>
                       <a:endParaRPr sz="1400" u="none" cap="none" strike="noStrike"/>
                     </a:p>
@@ -10275,7 +10275,7 @@
                         <a:rPr sz="1200">
                           <a:latin typeface="Arial"/>
                         </a:rPr>
-                        <a:t>50%</a:t>
+                        <a:t>85%</a:t>
                       </a:r>
                       <a:endParaRPr sz="1400" u="none" cap="none" strike="noStrike"/>
                     </a:p>
@@ -13025,7 +13025,7 @@
                         <a:rPr sz="1200">
                           <a:latin typeface="Arial"/>
                         </a:rPr>
-                        <a:t>20%</a:t>
+                        <a:t>5%</a:t>
                       </a:r>
                       <a:endParaRPr b="1" sz="850" u="none" cap="none" strike="noStrike"/>
                     </a:p>
@@ -13537,7 +13537,7 @@
                         <a:rPr sz="1200">
                           <a:latin typeface="Arial"/>
                         </a:rPr>
-                        <a:t>5%</a:t>
+                        <a:t>20%</a:t>
                       </a:r>
                       <a:endParaRPr b="1" sz="850" u="none" cap="none" strike="noStrike"/>
                     </a:p>
@@ -14049,7 +14049,7 @@
                         <a:rPr sz="1200">
                           <a:latin typeface="Arial"/>
                         </a:rPr>
-                        <a:t>20%</a:t>
+                        <a:t>50%</a:t>
                       </a:r>
                       <a:endParaRPr sz="1400" u="none" cap="none" strike="noStrike"/>
                     </a:p>
@@ -14146,11 +14146,11 @@
                       <a:r>
                         <a:rPr sz="1200" b="1">
                           <a:solidFill>
-                            <a:srgbClr val="00B050"/>
+                            <a:srgbClr val="FFC000"/>
                           </a:solidFill>
                           <a:latin typeface="Arial"/>
                         </a:rPr>
-                        <a:t>GO</a:t>
+                        <a:t>LTD GO</a:t>
                       </a:r>
                       <a:endParaRPr b="1" sz="850" u="none" cap="none" strike="noStrike">
                         <a:solidFill>
@@ -14463,7 +14463,7 @@
                         <a:rPr sz="1200">
                           <a:latin typeface="Arial"/>
                         </a:rPr>
-                        <a:t>0mm</a:t>
+                        <a:t>3.5mm</a:t>
                       </a:r>
                       <a:endParaRPr sz="1400" u="none" cap="none" strike="noStrike"/>
                     </a:p>
@@ -14561,7 +14561,7 @@
                         <a:rPr sz="1200">
                           <a:latin typeface="Arial"/>
                         </a:rPr>
-                        <a:t>50%</a:t>
+                        <a:t>85%</a:t>
                       </a:r>
                       <a:endParaRPr sz="1400" u="none" cap="none" strike="noStrike"/>
                     </a:p>
@@ -15073,7 +15073,7 @@
                         <a:rPr sz="1200">
                           <a:latin typeface="Arial"/>
                         </a:rPr>
-                        <a:t>50%</a:t>
+                        <a:t>20%</a:t>
                       </a:r>
                       <a:endParaRPr sz="1400" u="none" cap="none" strike="noStrike"/>
                     </a:p>
@@ -15170,11 +15170,11 @@
                       <a:r>
                         <a:rPr sz="1200" b="1">
                           <a:solidFill>
-                            <a:srgbClr val="FFC000"/>
+                            <a:srgbClr val="00B050"/>
                           </a:solidFill>
                           <a:latin typeface="Arial"/>
                         </a:rPr>
-                        <a:t>LTD GO</a:t>
+                        <a:t>GO</a:t>
                       </a:r>
                       <a:endParaRPr b="1" sz="850" u="none" cap="none" strike="noStrike">
                         <a:solidFill>
@@ -16675,7 +16675,7 @@
                         <a:rPr sz="1200">
                           <a:latin typeface="Arial"/>
                         </a:rPr>
-                        <a:t>50%</a:t>
+                        <a:t>5%</a:t>
                       </a:r>
                       <a:endParaRPr b="1" sz="850" u="none" cap="none" strike="noStrike"/>
                     </a:p>
@@ -16772,11 +16772,11 @@
                       <a:r>
                         <a:rPr sz="1200" b="1">
                           <a:solidFill>
-                            <a:srgbClr val="FFC000"/>
+                            <a:srgbClr val="00B050"/>
                           </a:solidFill>
                           <a:latin typeface="Arial"/>
                         </a:rPr>
-                        <a:t>LTD GO</a:t>
+                        <a:t>GO</a:t>
                       </a:r>
                       <a:endParaRPr sz="1400" u="none" cap="none" strike="noStrike">
                         <a:solidFill>
@@ -17699,7 +17699,7 @@
                         <a:rPr sz="1200">
                           <a:latin typeface="Arial"/>
                         </a:rPr>
-                        <a:t>20%</a:t>
+                        <a:t>50%</a:t>
                       </a:r>
                       <a:endParaRPr sz="1400" u="none" cap="none" strike="noStrike"/>
                     </a:p>
@@ -17796,11 +17796,11 @@
                       <a:r>
                         <a:rPr sz="1200" b="1">
                           <a:solidFill>
-                            <a:srgbClr val="00B050"/>
+                            <a:srgbClr val="FFC000"/>
                           </a:solidFill>
                           <a:latin typeface="Arial"/>
                         </a:rPr>
-                        <a:t>GO</a:t>
+                        <a:t>LTD GO</a:t>
                       </a:r>
                       <a:endParaRPr b="1" sz="850" u="none" cap="none" strike="noStrike">
                         <a:solidFill>
@@ -18113,7 +18113,7 @@
                         <a:rPr sz="1200">
                           <a:latin typeface="Arial"/>
                         </a:rPr>
-                        <a:t>0mm</a:t>
+                        <a:t>0.2mm</a:t>
                       </a:r>
                       <a:endParaRPr sz="1400" u="none" cap="none" strike="noStrike"/>
                     </a:p>
@@ -18211,7 +18211,7 @@
                         <a:rPr sz="1200">
                           <a:latin typeface="Arial"/>
                         </a:rPr>
-                        <a:t>20%</a:t>
+                        <a:t>85%</a:t>
                       </a:r>
                       <a:endParaRPr sz="1400" u="none" cap="none" strike="noStrike"/>
                     </a:p>
@@ -18308,11 +18308,11 @@
                       <a:r>
                         <a:rPr sz="1200" b="1">
                           <a:solidFill>
-                            <a:srgbClr val="00B050"/>
+                            <a:srgbClr val="FFC000"/>
                           </a:solidFill>
                           <a:latin typeface="Arial"/>
                         </a:rPr>
-                        <a:t>GO</a:t>
+                        <a:t>LTD GO</a:t>
                       </a:r>
                       <a:endParaRPr b="1" sz="850" u="none" cap="none" strike="noStrike">
                         <a:solidFill>
@@ -18625,7 +18625,7 @@
                         <a:rPr sz="1200">
                           <a:latin typeface="Arial"/>
                         </a:rPr>
-                        <a:t>1.4mm</a:t>
+                        <a:t>0mm</a:t>
                       </a:r>
                       <a:endParaRPr sz="1400" u="none" cap="none" strike="noStrike"/>
                     </a:p>
@@ -18723,7 +18723,7 @@
                         <a:rPr sz="1200">
                           <a:latin typeface="Arial"/>
                         </a:rPr>
-                        <a:t>75%</a:t>
+                        <a:t>20%</a:t>
                       </a:r>
                       <a:endParaRPr sz="1400" u="none" cap="none" strike="noStrike"/>
                     </a:p>
@@ -18820,11 +18820,11 @@
                       <a:r>
                         <a:rPr sz="1200" b="1">
                           <a:solidFill>
-                            <a:srgbClr val="FFC000"/>
+                            <a:srgbClr val="00B050"/>
                           </a:solidFill>
                           <a:latin typeface="Arial"/>
                         </a:rPr>
-                        <a:t>LTD GO</a:t>
+                        <a:t>GO</a:t>
                       </a:r>
                       <a:endParaRPr b="1" sz="850" u="none" cap="none" strike="noStrike">
                         <a:solidFill>
@@ -20325,7 +20325,7 @@
                         <a:rPr sz="1200">
                           <a:latin typeface="Arial"/>
                         </a:rPr>
-                        <a:t>50%</a:t>
+                        <a:t>5%</a:t>
                       </a:r>
                       <a:endParaRPr b="1" sz="850" u="none" cap="none" strike="noStrike"/>
                     </a:p>
@@ -20422,11 +20422,11 @@
                       <a:r>
                         <a:rPr sz="1200" b="1">
                           <a:solidFill>
-                            <a:srgbClr val="FFC000"/>
+                            <a:srgbClr val="00B050"/>
                           </a:solidFill>
                           <a:latin typeface="Arial"/>
                         </a:rPr>
-                        <a:t>LTD GO</a:t>
+                        <a:t>GO</a:t>
                       </a:r>
                       <a:endParaRPr sz="1400" u="none" cap="none" strike="noStrike">
                         <a:solidFill>
@@ -21349,7 +21349,7 @@
                         <a:rPr sz="1200">
                           <a:latin typeface="Arial"/>
                         </a:rPr>
-                        <a:t>20%</a:t>
+                        <a:t>50%</a:t>
                       </a:r>
                       <a:endParaRPr sz="1400" u="none" cap="none" strike="noStrike"/>
                     </a:p>
@@ -21446,11 +21446,11 @@
                       <a:r>
                         <a:rPr sz="1200" b="1">
                           <a:solidFill>
-                            <a:srgbClr val="00B050"/>
+                            <a:srgbClr val="FFC000"/>
                           </a:solidFill>
                           <a:latin typeface="Arial"/>
                         </a:rPr>
-                        <a:t>GO</a:t>
+                        <a:t>LTD GO</a:t>
                       </a:r>
                       <a:endParaRPr b="1" sz="850" u="none" cap="none" strike="noStrike">
                         <a:solidFill>
@@ -22275,7 +22275,7 @@
                         <a:rPr sz="1200">
                           <a:latin typeface="Arial"/>
                         </a:rPr>
-                        <a:t>0.2mm</a:t>
+                        <a:t>0mm</a:t>
                       </a:r>
                       <a:endParaRPr sz="1400" u="none" cap="none" strike="noStrike"/>
                     </a:p>
@@ -22373,7 +22373,7 @@
                         <a:rPr sz="1200">
                           <a:latin typeface="Arial"/>
                         </a:rPr>
-                        <a:t>75%</a:t>
+                        <a:t>20%</a:t>
                       </a:r>
                       <a:endParaRPr sz="1400" u="none" cap="none" strike="noStrike"/>
                     </a:p>
@@ -22470,11 +22470,11 @@
                       <a:r>
                         <a:rPr sz="1200" b="1">
                           <a:solidFill>
-                            <a:srgbClr val="FFC000"/>
+                            <a:srgbClr val="00B050"/>
                           </a:solidFill>
                           <a:latin typeface="Arial"/>
                         </a:rPr>
-                        <a:t>LTD GO</a:t>
+                        <a:t>GO</a:t>
                       </a:r>
                       <a:endParaRPr b="1" sz="850" u="none" cap="none" strike="noStrike">
                         <a:solidFill>
@@ -23975,7 +23975,7 @@
                         <a:rPr sz="1200">
                           <a:latin typeface="Arial"/>
                         </a:rPr>
-                        <a:t>50%</a:t>
+                        <a:t>5%</a:t>
                       </a:r>
                       <a:endParaRPr b="1" sz="850" u="none" cap="none" strike="noStrike"/>
                     </a:p>
@@ -24072,11 +24072,11 @@
                       <a:r>
                         <a:rPr sz="1200" b="1">
                           <a:solidFill>
-                            <a:srgbClr val="FFC000"/>
+                            <a:srgbClr val="00B050"/>
                           </a:solidFill>
                           <a:latin typeface="Arial"/>
                         </a:rPr>
-                        <a:t>LTD GO</a:t>
+                        <a:t>GO</a:t>
                       </a:r>
                       <a:endParaRPr sz="1400" u="none" cap="none" strike="noStrike">
                         <a:solidFill>
@@ -24999,7 +24999,7 @@
                         <a:rPr sz="1200">
                           <a:latin typeface="Arial"/>
                         </a:rPr>
-                        <a:t>20%</a:t>
+                        <a:t>50%</a:t>
                       </a:r>
                       <a:endParaRPr sz="1400" u="none" cap="none" strike="noStrike"/>
                     </a:p>
@@ -25096,11 +25096,11 @@
                       <a:r>
                         <a:rPr sz="1200" b="1">
                           <a:solidFill>
-                            <a:srgbClr val="00B050"/>
+                            <a:srgbClr val="FFC000"/>
                           </a:solidFill>
                           <a:latin typeface="Arial"/>
                         </a:rPr>
-                        <a:t>GO</a:t>
+                        <a:t>LTD GO</a:t>
                       </a:r>
                       <a:endParaRPr b="1" sz="850" u="none" cap="none" strike="noStrike">
                         <a:solidFill>
@@ -25925,7 +25925,7 @@
                         <a:rPr sz="1200">
                           <a:latin typeface="Arial"/>
                         </a:rPr>
-                        <a:t>0.2mm</a:t>
+                        <a:t>0mm</a:t>
                       </a:r>
                       <a:endParaRPr sz="1400" u="none" cap="none" strike="noStrike"/>
                     </a:p>
@@ -26023,7 +26023,7 @@
                         <a:rPr sz="1200">
                           <a:latin typeface="Arial"/>
                         </a:rPr>
-                        <a:t>75%</a:t>
+                        <a:t>20%</a:t>
                       </a:r>
                       <a:endParaRPr sz="1400" u="none" cap="none" strike="noStrike"/>
                     </a:p>
@@ -26120,11 +26120,11 @@
                       <a:r>
                         <a:rPr sz="1200" b="1">
                           <a:solidFill>
-                            <a:srgbClr val="FFC000"/>
+                            <a:srgbClr val="00B050"/>
                           </a:solidFill>
                           <a:latin typeface="Arial"/>
                         </a:rPr>
-                        <a:t>LTD GO</a:t>
+                        <a:t>GO</a:t>
                       </a:r>
                       <a:endParaRPr b="1" sz="850" u="none" cap="none" strike="noStrike">
                         <a:solidFill>

</xml_diff>